<commit_message>
kevin-stock-research 0.4.0: engineering-visuals 與 integrated-deck；SVG 文字轉外框修正無法顯示
- visuals.py：diagram spec 產工程圖，SVG 文字一律轉字形外框（Drive 預覽、未裝思源黑體也能顯示），字型自動探測 Noto Sans TC→微軟正黑體→蘋方→fontconfig，Segoe UI/Arial/DejaVu 補 μΩ±，缺字報錯；visual-build/visual-outline/visual-check
- deck.py：profiles/deck_styles.json（10 配色×3 字型）、set-deck-style、九種版型原生圖表 PPTX（長條圖 0 軸）、中文預設微軟正黑體、deck-check（溢字/出界/0軸/來源/符號/非投資建議）、--pdf、deck-fonts
- 新 skills engineering-visuals、integrated-deck；router full 流程與 MODES 更新；requirements 加 fonttools/brotli/cairosvg/python-pptx/Pillow；測試 103→112
- 竹陞 6739：7 張 SVG 轉外框（活字原檔留在 原始碼/）、PNG 重產、簡報與 Word 內嵌圖更新、deck_style 07+C、簡報字型改微軟正黑體、修 p18 換行與 p19 符號、輸出 PDF 並目檢

Co-Authored-By: Claude Opus 5.5 <noreply@anthropic.com>
Claude-Session: https://claude.ai/code/session_0149DeunJtKxehWsctn5HHVe
</commit_message>
<xml_diff>
--- a/研究資料/TPEX-6739/整合簡報/竹陞6739_產品供應鏈與工程競爭分析_23頁_20261002.pptx
+++ b/研究資料/TPEX-6739/整合簡報/竹陞6739_產品供應鏈與工程競爭分析_23頁_20261002.pptx
@@ -5421,6 +5421,7 @@
                 <a:solidFill>
                   <a:schemeClr val="bg1"/>
                 </a:solidFill>
+                <a:ea typeface="Microsoft JhengHei"/>
               </a:rPr>
               <a:t>竹陞科技 6739</a:t>
             </a:r>
@@ -5459,6 +5460,7 @@
                 <a:solidFill>
                   <a:schemeClr val="bg1"/>
                 </a:solidFill>
+                <a:ea typeface="Microsoft JhengHei"/>
               </a:rPr>
               <a:t>產品、供應鏈與工程競爭分析｜半導體 AI 智慧製造</a:t>
             </a:r>
@@ -5495,6 +5497,7 @@
                 <a:solidFill>
                   <a:schemeClr val="bg2"/>
                 </a:solidFill>
+                <a:ea typeface="Microsoft JhengHei"/>
               </a:rPr>
               <a:t>資料截止 2026-10-02｜股價基準 2026/09/30 收盤 NT$1,135｜比照《健策3653研究》架構</a:t>
             </a:r>
@@ -5558,6 +5561,7 @@
                 <a:solidFill>
                   <a:schemeClr val="bg1"/>
                 </a:solidFill>
+                <a:ea typeface="Microsoft JhengHei"/>
               </a:rPr>
               <a:t>供應鏈與競爭</a:t>
             </a:r>
@@ -5596,6 +5600,7 @@
                 <a:solidFill>
                   <a:schemeClr val="accent3"/>
                 </a:solidFill>
+                <a:ea typeface="Microsoft JhengHei"/>
               </a:rPr>
               <a:t>設備原廠與晶圓廠之間的後裝智慧化層</a:t>
             </a:r>
@@ -5659,6 +5664,7 @@
                 <a:solidFill>
                   <a:schemeClr val="accent1"/>
                 </a:solidFill>
+                <a:ea typeface="Microsoft JhengHei"/>
               </a:rPr>
               <a:t>價值鏈位置：不賣機台，賣跨品牌整合</a:t>
             </a:r>
@@ -5716,6 +5722,10 @@
             <a:prstDash val="solid"/>
           </a:ln>
         </p:spPr>
+        <p:txBody>
+          <a:bodyPr/>
+          <a:p/>
+        </p:txBody>
       </p:sp>
       <p:sp>
         <p:nvSpPr>
@@ -5749,6 +5759,7 @@
                 <a:solidFill>
                   <a:schemeClr val="tx1"/>
                 </a:solidFill>
+                <a:ea typeface="Microsoft JhengHei"/>
               </a:rPr>
               <a:t>判讀</a:t>
             </a:r>
@@ -5766,6 +5777,7 @@
                 <a:solidFill>
                   <a:schemeClr val="accent5"/>
                 </a:solidFill>
+                <a:ea typeface="Microsoft JhengHei"/>
               </a:rPr>
               <a:t>上游為通用感測與工控元件，議價壓力低</a:t>
             </a:r>
@@ -5783,6 +5795,7 @@
                 <a:solidFill>
                   <a:schemeClr val="accent5"/>
                 </a:solidFill>
+                <a:ea typeface="Microsoft JhengHei"/>
               </a:rPr>
               <a:t>下游集中在晶圓代工、記憶體、先進封裝大廠</a:t>
             </a:r>
@@ -5800,6 +5813,7 @@
                 <a:solidFill>
                   <a:schemeClr val="accent5"/>
                 </a:solidFill>
+                <a:ea typeface="Microsoft JhengHei"/>
               </a:rPr>
               <a:t>最大威脅來自設備原廠自行智慧化</a:t>
             </a:r>
@@ -5908,6 +5922,7 @@
                 <a:solidFill>
                   <a:schemeClr val="accent1"/>
                 </a:solidFill>
+                <a:ea typeface="Microsoft JhengHei"/>
               </a:rPr>
               <a:t>導入流程：Early Involvement → 標配 → Copy</a:t>
             </a:r>
@@ -5965,6 +5980,10 @@
             <a:prstDash val="solid"/>
           </a:ln>
         </p:spPr>
+        <p:txBody>
+          <a:bodyPr/>
+          <a:p/>
+        </p:txBody>
       </p:sp>
       <p:sp>
         <p:nvSpPr>
@@ -5998,6 +6017,7 @@
                 <a:solidFill>
                   <a:schemeClr val="tx1"/>
                 </a:solidFill>
+                <a:ea typeface="Microsoft JhengHei"/>
               </a:rPr>
               <a:t>商業模式</a:t>
             </a:r>
@@ -6015,6 +6035,7 @@
                 <a:solidFill>
                   <a:schemeClr val="accent5"/>
                 </a:solidFill>
+                <a:ea typeface="Microsoft JhengHei"/>
               </a:rPr>
               <a:t>Pilot Run 即參與，量產後成標配</a:t>
             </a:r>
@@ -6032,6 +6053,7 @@
                 <a:solidFill>
                   <a:schemeClr val="accent5"/>
                 </a:solidFill>
+                <a:ea typeface="Microsoft JhengHei"/>
               </a:rPr>
               <a:t>隨客戶擴廠複製到新加坡、美國、日本</a:t>
             </a:r>
@@ -6049,6 +6071,7 @@
                 <a:solidFill>
                   <a:schemeClr val="accent5"/>
                 </a:solidFill>
+                <a:ea typeface="Microsoft JhengHei"/>
               </a:rPr>
               <a:t>收入於驗收時點認列；合約負債 0.82 億</a:t>
             </a:r>
@@ -6157,6 +6180,7 @@
                 <a:solidFill>
                   <a:schemeClr val="accent1"/>
                 </a:solidFill>
+                <a:ea typeface="Microsoft JhengHei"/>
               </a:rPr>
               <a:t>客戶與地區：集中度是最大風險</a:t>
             </a:r>
@@ -6297,6 +6321,7 @@
                 <a:solidFill>
                   <a:schemeClr val="accent1"/>
                 </a:solidFill>
+                <a:ea typeface="Microsoft JhengHei"/>
               </a:rPr>
               <a:t>競爭格局：威脅來自原廠與客戶自建</a:t>
             </a:r>
@@ -6346,6 +6371,7 @@
                           <a:solidFill>
                             <a:srgbClr val="FFFFFF"/>
                           </a:solidFill>
+                          <a:ea typeface="Microsoft JhengHei"/>
                         </a:rPr>
                         <a:t>競爭／替代來源</a:t>
                       </a:r>
@@ -6407,6 +6433,7 @@
                           <a:solidFill>
                             <a:srgbClr val="FFFFFF"/>
                           </a:solidFill>
+                          <a:ea typeface="Microsoft JhengHei"/>
                         </a:rPr>
                         <a:t>代表者</a:t>
                       </a:r>
@@ -6468,6 +6495,7 @@
                           <a:solidFill>
                             <a:srgbClr val="FFFFFF"/>
                           </a:solidFill>
+                          <a:ea typeface="Microsoft JhengHei"/>
                         </a:rPr>
                         <a:t>威脅</a:t>
                       </a:r>
@@ -6529,6 +6557,7 @@
                           <a:solidFill>
                             <a:srgbClr val="FFFFFF"/>
                           </a:solidFill>
+                          <a:ea typeface="Microsoft JhengHei"/>
                         </a:rPr>
                         <a:t>竹陞的差異化</a:t>
                       </a:r>
@@ -6592,6 +6621,7 @@
                           <a:solidFill>
                             <a:srgbClr val="14323A"/>
                           </a:solidFill>
+                          <a:ea typeface="Microsoft JhengHei"/>
                         </a:rPr>
                         <a:t>設備原廠智慧化</a:t>
                       </a:r>
@@ -6653,6 +6683,7 @@
                           <a:solidFill>
                             <a:srgbClr val="14323A"/>
                           </a:solidFill>
+                          <a:ea typeface="Microsoft JhengHei"/>
                         </a:rPr>
                         <a:t>Applied Materials、Lam、TEL、KLA</a:t>
                       </a:r>
@@ -6714,6 +6745,7 @@
                           <a:solidFill>
                             <a:srgbClr val="14323A"/>
                           </a:solidFill>
+                          <a:ea typeface="Microsoft JhengHei"/>
                         </a:rPr>
                         <a:t>高</a:t>
                       </a:r>
@@ -6775,6 +6807,7 @@
                           <a:solidFill>
                             <a:srgbClr val="14323A"/>
                           </a:solidFill>
+                          <a:ea typeface="Microsoft JhengHei"/>
                         </a:rPr>
                         <a:t>跨品牌、跨世代整合；舊機台改造</a:t>
                       </a:r>
@@ -6838,6 +6871,7 @@
                           <a:solidFill>
                             <a:srgbClr val="14323A"/>
                           </a:solidFill>
+                          <a:ea typeface="Microsoft JhengHei"/>
                         </a:rPr>
                         <a:t>晶圓廠自研</a:t>
                       </a:r>
@@ -6899,6 +6933,7 @@
                           <a:solidFill>
                             <a:srgbClr val="14323A"/>
                           </a:solidFill>
+                          <a:ea typeface="Microsoft JhengHei"/>
                         </a:rPr>
                         <a:t>台積電、美光內部團隊</a:t>
                       </a:r>
@@ -6960,6 +6995,7 @@
                           <a:solidFill>
                             <a:srgbClr val="14323A"/>
                           </a:solidFill>
+                          <a:ea typeface="Microsoft JhengHei"/>
                         </a:rPr>
                         <a:t>中</a:t>
                       </a:r>
@@ -7021,6 +7057,7 @@
                           <a:solidFill>
                             <a:srgbClr val="14323A"/>
                           </a:solidFill>
+                          <a:ea typeface="Microsoft JhengHei"/>
                         </a:rPr>
                         <a:t>已是標配、裝機基礎 7–8 千台</a:t>
                       </a:r>
@@ -7084,6 +7121,7 @@
                           <a:solidFill>
                             <a:srgbClr val="14323A"/>
                           </a:solidFill>
+                          <a:ea typeface="Microsoft JhengHei"/>
                         </a:rPr>
                         <a:t>國際工業自動化</a:t>
                       </a:r>
@@ -7145,6 +7183,7 @@
                           <a:solidFill>
                             <a:srgbClr val="14323A"/>
                           </a:solidFill>
+                          <a:ea typeface="Microsoft JhengHei"/>
                         </a:rPr>
                         <a:t>Siemens、Rockwell、Schneider</a:t>
                       </a:r>
@@ -7206,6 +7245,7 @@
                           <a:solidFill>
                             <a:srgbClr val="14323A"/>
                           </a:solidFill>
+                          <a:ea typeface="Microsoft JhengHei"/>
                         </a:rPr>
                         <a:t>低到中</a:t>
                       </a:r>
@@ -7267,6 +7307,7 @@
                           <a:solidFill>
                             <a:srgbClr val="14323A"/>
                           </a:solidFill>
+                          <a:ea typeface="Microsoft JhengHei"/>
                         </a:rPr>
                         <a:t>半導體製程 know-how 深</a:t>
                       </a:r>
@@ -7330,6 +7371,7 @@
                           <a:solidFill>
                             <a:srgbClr val="14323A"/>
                           </a:solidFill>
+                          <a:ea typeface="Microsoft JhengHei"/>
                         </a:rPr>
                         <a:t>台灣整合商</a:t>
                       </a:r>
@@ -7391,6 +7433,7 @@
                           <a:solidFill>
                             <a:srgbClr val="14323A"/>
                           </a:solidFill>
+                          <a:ea typeface="Microsoft JhengHei"/>
                         </a:rPr>
                         <a:t>盟立 2464、迅得 6438、帆宣 6196</a:t>
                       </a:r>
@@ -7452,6 +7495,7 @@
                           <a:solidFill>
                             <a:srgbClr val="14323A"/>
                           </a:solidFill>
+                          <a:ea typeface="Microsoft JhengHei"/>
                         </a:rPr>
                         <a:t>低</a:t>
                       </a:r>
@@ -7513,6 +7557,7 @@
                           <a:solidFill>
                             <a:srgbClr val="14323A"/>
                           </a:solidFill>
+                          <a:ea typeface="Microsoft JhengHei"/>
                         </a:rPr>
                         <a:t>機台端操作與監測，毛利率 65%+</a:t>
                       </a:r>
@@ -7592,6 +7637,10 @@
             <a:prstDash val="solid"/>
           </a:ln>
         </p:spPr>
+        <p:txBody>
+          <a:bodyPr/>
+          <a:p/>
+        </p:txBody>
       </p:sp>
       <p:sp>
         <p:nvSpPr>
@@ -7625,6 +7674,7 @@
                 <a:solidFill>
                   <a:schemeClr val="tx1"/>
                 </a:solidFill>
+                <a:ea typeface="Microsoft JhengHei"/>
               </a:rPr>
               <a:t>觀察指標</a:t>
             </a:r>
@@ -7642,6 +7692,7 @@
                 <a:solidFill>
                   <a:schemeClr val="accent5"/>
                 </a:solidFill>
+                <a:ea typeface="Microsoft JhengHei"/>
               </a:rPr>
               <a:t>新產線標配率與相容機型數是否持續增加；設備原廠是否在新機台內建同等功能；H 客戶占比是否下降（客戶分散）</a:t>
             </a:r>
@@ -7750,6 +7801,7 @@
                 <a:solidFill>
                   <a:schemeClr val="bg1"/>
                 </a:solidFill>
+                <a:ea typeface="Microsoft JhengHei"/>
               </a:rPr>
               <a:t>財務與估值</a:t>
             </a:r>
@@ -7788,6 +7840,7 @@
                 <a:solidFill>
                   <a:schemeClr val="accent3"/>
                 </a:solidFill>
+                <a:ea typeface="Microsoft JhengHei"/>
               </a:rPr>
               <a:t>營業槓桿、Kevin 雙層錨定模型、同業相對估值</a:t>
             </a:r>
@@ -7851,6 +7904,7 @@
                 <a:solidFill>
                   <a:schemeClr val="accent1"/>
                 </a:solidFill>
+                <a:ea typeface="Microsoft JhengHei"/>
               </a:rPr>
               <a:t>月營收：連 15 個月創新高，YoY 維持近倍增</a:t>
             </a:r>
@@ -7900,6 +7954,10 @@
             <a:prstDash val="solid"/>
           </a:ln>
         </p:spPr>
+        <p:txBody>
+          <a:bodyPr/>
+          <a:p/>
+        </p:txBody>
       </p:sp>
       <p:sp>
         <p:nvSpPr>
@@ -7933,6 +7991,7 @@
                 <a:solidFill>
                   <a:schemeClr val="tx1"/>
                 </a:solidFill>
+                <a:ea typeface="Microsoft JhengHei"/>
               </a:rPr>
               <a:t>指引與驗證</a:t>
             </a:r>
@@ -7950,6 +8009,7 @@
                 <a:solidFill>
                   <a:schemeClr val="accent5"/>
                 </a:solidFill>
+                <a:ea typeface="Microsoft JhengHei"/>
               </a:rPr>
               <a:t>Q3 營收 QoQ +21～24%</a:t>
             </a:r>
@@ -7967,6 +8027,7 @@
                 <a:solidFill>
                   <a:schemeClr val="accent5"/>
                 </a:solidFill>
+                <a:ea typeface="Microsoft JhengHei"/>
               </a:rPr>
               <a:t>→ 9 月需 1.49–1.60 億</a:t>
             </a:r>
@@ -7984,6 +8045,7 @@
                 <a:solidFill>
                   <a:schemeClr val="accent5"/>
                 </a:solidFill>
+                <a:ea typeface="Microsoft JhengHei"/>
               </a:rPr>
               <a:t>全年 15.3–16.1 億</a:t>
             </a:r>
@@ -8001,6 +8063,7 @@
                 <a:solidFill>
                   <a:schemeClr val="accent5"/>
                 </a:solidFill>
+                <a:ea typeface="Microsoft JhengHei"/>
               </a:rPr>
               <a:t>→ 9–12 月月均 1.50–1.70 億</a:t>
             </a:r>
@@ -8018,6 +8081,7 @@
                 <a:solidFill>
                   <a:schemeClr val="accent5"/>
                 </a:solidFill>
+                <a:ea typeface="Microsoft JhengHei"/>
               </a:rPr>
               <a:t>10/10 前公布 9 月營收</a:t>
             </a:r>
@@ -8126,6 +8190,7 @@
                 <a:solidFill>
                   <a:schemeClr val="accent1"/>
                 </a:solidFill>
+                <a:ea typeface="Microsoft JhengHei"/>
               </a:rPr>
               <a:t>三率：營業槓桿推升營益率到 58%</a:t>
             </a:r>
@@ -8175,6 +8240,10 @@
             <a:prstDash val="solid"/>
           </a:ln>
         </p:spPr>
+        <p:txBody>
+          <a:bodyPr/>
+          <a:p/>
+        </p:txBody>
       </p:sp>
       <p:sp>
         <p:nvSpPr>
@@ -8208,6 +8277,7 @@
                 <a:solidFill>
                   <a:schemeClr val="tx1"/>
                 </a:solidFill>
+                <a:ea typeface="Microsoft JhengHei"/>
               </a:rPr>
               <a:t>2026H1 盈餘品質</a:t>
             </a:r>
@@ -8225,6 +8295,7 @@
                 <a:solidFill>
                   <a:schemeClr val="accent5"/>
                 </a:solidFill>
+                <a:ea typeface="Microsoft JhengHei"/>
               </a:rPr>
               <a:t>營收 6.44 億、淨利 3.11 億</a:t>
             </a:r>
@@ -8242,6 +8313,7 @@
                 <a:solidFill>
                   <a:schemeClr val="accent5"/>
                 </a:solidFill>
+                <a:ea typeface="Microsoft JhengHei"/>
               </a:rPr>
               <a:t>業外占稅前 2.2%（利息收入）</a:t>
             </a:r>
@@ -8259,6 +8331,7 @@
                 <a:solidFill>
                   <a:schemeClr val="accent5"/>
                 </a:solidFill>
+                <a:ea typeface="Microsoft JhengHei"/>
               </a:rPr>
               <a:t>無少數股權，W＝1</a:t>
             </a:r>
@@ -8276,6 +8349,7 @@
                 <a:solidFill>
                   <a:schemeClr val="accent5"/>
                 </a:solidFill>
+                <a:ea typeface="Microsoft JhengHei"/>
               </a:rPr>
               <a:t>費用率 14.1% → 8.9%</a:t>
             </a:r>
@@ -8293,6 +8367,7 @@
                 <a:solidFill>
                   <a:schemeClr val="accent5"/>
                 </a:solidFill>
+                <a:ea typeface="Microsoft JhengHei"/>
               </a:rPr>
               <a:t>有效稅率 19.5%</a:t>
             </a:r>
@@ -8401,6 +8476,7 @@
                 <a:solidFill>
                   <a:schemeClr val="accent1"/>
                 </a:solidFill>
+                <a:ea typeface="Microsoft JhengHei"/>
               </a:rPr>
               <a:t>Kevin 雙層錨定模型（潛力股，00935）</a:t>
             </a:r>
@@ -8438,7 +8514,7 @@
                   <a:schemeClr val="accent4"/>
                 </a:solidFill>
                 <a:latin typeface="Impact" pitchFamily="34" charset="0"/>
-                <a:ea typeface="Impact" pitchFamily="34" charset="-122"/>
+                <a:ea typeface="Microsoft JhengHei" pitchFamily="34" charset="-122"/>
                 <a:cs typeface="Impact" pitchFamily="34" charset="-120"/>
               </a:rPr>
               <a:t>983</a:t>
@@ -8476,6 +8552,7 @@
                 <a:solidFill>
                   <a:schemeClr val="accent5"/>
                 </a:solidFill>
+                <a:ea typeface="Microsoft JhengHei"/>
               </a:rPr>
               <a:t>情境 A 目標價（1–8 月年化）</a:t>
             </a:r>
@@ -8513,7 +8590,7 @@
                   <a:schemeClr val="accent1"/>
                 </a:solidFill>
                 <a:latin typeface="Impact" pitchFamily="34" charset="0"/>
-                <a:ea typeface="Impact" pitchFamily="34" charset="-122"/>
+                <a:ea typeface="Microsoft JhengHei" pitchFamily="34" charset="-122"/>
                 <a:cs typeface="Impact" pitchFamily="34" charset="-120"/>
               </a:rPr>
               <a:t>1,128</a:t>
@@ -8551,6 +8628,7 @@
                 <a:solidFill>
                   <a:schemeClr val="accent5"/>
                 </a:solidFill>
+                <a:ea typeface="Microsoft JhengHei"/>
               </a:rPr>
               <a:t>情境 B 目標價（近月動能）</a:t>
             </a:r>
@@ -8583,12 +8661,12 @@
               <a:buNone/>
             </a:pPr>
             <a:r>
-              <a:rPr lang="en-US" sz="4000" b="1" dirty="0">
+              <a:rPr lang="en-US" sz="3200" b="1" dirty="0">
                 <a:solidFill>
                   <a:schemeClr val="accent1"/>
                 </a:solidFill>
                 <a:latin typeface="Impact" pitchFamily="34" charset="0"/>
-                <a:ea typeface="Impact" pitchFamily="34" charset="-122"/>
+                <a:ea typeface="Microsoft JhengHei" pitchFamily="34" charset="-122"/>
                 <a:cs typeface="Impact" pitchFamily="34" charset="-120"/>
               </a:rPr>
               <a:t>1,160–1,254</a:t>
@@ -8626,6 +8704,7 @@
                 <a:solidFill>
                   <a:schemeClr val="accent5"/>
                 </a:solidFill>
+                <a:ea typeface="Microsoft JhengHei"/>
               </a:rPr>
               <a:t>參考：代入公司全年指引</a:t>
             </a:r>
@@ -8674,6 +8753,7 @@
                           <a:solidFill>
                             <a:srgbClr val="FFFFFF"/>
                           </a:solidFill>
+                          <a:ea typeface="Microsoft JhengHei"/>
                         </a:rPr>
                         <a:t>項目</a:t>
                       </a:r>
@@ -8735,6 +8815,7 @@
                           <a:solidFill>
                             <a:srgbClr val="FFFFFF"/>
                           </a:solidFill>
+                          <a:ea typeface="Microsoft JhengHei"/>
                         </a:rPr>
                         <a:t>情境 A</a:t>
                       </a:r>
@@ -8796,6 +8877,7 @@
                           <a:solidFill>
                             <a:srgbClr val="FFFFFF"/>
                           </a:solidFill>
+                          <a:ea typeface="Microsoft JhengHei"/>
                         </a:rPr>
                         <a:t>情境 B</a:t>
                       </a:r>
@@ -8859,6 +8941,7 @@
                           <a:solidFill>
                             <a:srgbClr val="14323A"/>
                           </a:solidFill>
+                          <a:ea typeface="Microsoft JhengHei"/>
                         </a:rPr>
                         <a:t>年化營收（千元）</a:t>
                       </a:r>
@@ -8920,6 +9003,7 @@
                           <a:solidFill>
                             <a:srgbClr val="14323A"/>
                           </a:solidFill>
+                          <a:ea typeface="Microsoft JhengHei"/>
                         </a:rPr>
                         <a:t>1,395,321</a:t>
                       </a:r>
@@ -8981,6 +9065,7 @@
                           <a:solidFill>
                             <a:srgbClr val="14323A"/>
                           </a:solidFill>
+                          <a:ea typeface="Microsoft JhengHei"/>
                         </a:rPr>
                         <a:t>1,502,676</a:t>
                       </a:r>
@@ -9044,6 +9129,7 @@
                           <a:solidFill>
                             <a:srgbClr val="14323A"/>
                           </a:solidFill>
+                          <a:ea typeface="Microsoft JhengHei"/>
                         </a:rPr>
                         <a:t>淨利率 H</a:t>
                       </a:r>
@@ -9105,6 +9191,7 @@
                           <a:solidFill>
                             <a:srgbClr val="14323A"/>
                           </a:solidFill>
+                          <a:ea typeface="Microsoft JhengHei"/>
                         </a:rPr>
                         <a:t>48.22%（H1）</a:t>
                       </a:r>
@@ -9166,6 +9253,7 @@
                           <a:solidFill>
                             <a:srgbClr val="14323A"/>
                           </a:solidFill>
+                          <a:ea typeface="Microsoft JhengHei"/>
                         </a:rPr>
                         <a:t>48.93%（Q2）</a:t>
                       </a:r>
@@ -9229,6 +9317,7 @@
                           <a:solidFill>
                             <a:srgbClr val="14323A"/>
                           </a:solidFill>
+                          <a:ea typeface="Microsoft JhengHei"/>
                         </a:rPr>
                         <a:t>預期 EPS N</a:t>
                       </a:r>
@@ -9290,6 +9379,7 @@
                           <a:solidFill>
                             <a:srgbClr val="14323A"/>
                           </a:solidFill>
+                          <a:ea typeface="Microsoft JhengHei"/>
                         </a:rPr>
                         <a:t>28.76</a:t>
                       </a:r>
@@ -9351,6 +9441,7 @@
                           <a:solidFill>
                             <a:srgbClr val="14323A"/>
                           </a:solidFill>
+                          <a:ea typeface="Microsoft JhengHei"/>
                         </a:rPr>
                         <a:t>31.43</a:t>
                       </a:r>
@@ -9414,6 +9505,7 @@
                           <a:solidFill>
                             <a:srgbClr val="14323A"/>
                           </a:solidFill>
+                          <a:ea typeface="Microsoft JhengHei"/>
                         </a:rPr>
                         <a:t>成長率 O</a:t>
                       </a:r>
@@ -9475,6 +9567,7 @@
                           <a:solidFill>
                             <a:srgbClr val="14323A"/>
                           </a:solidFill>
+                          <a:ea typeface="Microsoft JhengHei"/>
                         </a:rPr>
                         <a:t>+78.3%</a:t>
                       </a:r>
@@ -9536,6 +9629,7 @@
                           <a:solidFill>
                             <a:srgbClr val="14323A"/>
                           </a:solidFill>
+                          <a:ea typeface="Microsoft JhengHei"/>
                         </a:rPr>
                         <a:t>+94.9%</a:t>
                       </a:r>
@@ -9599,6 +9693,7 @@
                           <a:solidFill>
                             <a:srgbClr val="14323A"/>
                           </a:solidFill>
+                          <a:ea typeface="Microsoft JhengHei"/>
                         </a:rPr>
                         <a:t>P／Q</a:t>
                       </a:r>
@@ -9660,6 +9755,7 @@
                           <a:solidFill>
                             <a:srgbClr val="14323A"/>
                           </a:solidFill>
+                          <a:ea typeface="Microsoft JhengHei"/>
                         </a:rPr>
                         <a:t>32.69／35.69</a:t>
                       </a:r>
@@ -9721,6 +9817,7 @@
                           <a:solidFill>
                             <a:srgbClr val="14323A"/>
                           </a:solidFill>
+                          <a:ea typeface="Microsoft JhengHei"/>
                         </a:rPr>
                         <a:t>33.58／38.19</a:t>
                       </a:r>
@@ -9784,6 +9881,7 @@
                           <a:solidFill>
                             <a:srgbClr val="14323A"/>
                           </a:solidFill>
+                          <a:ea typeface="Microsoft JhengHei"/>
                         </a:rPr>
                         <a:t>目標價 T</a:t>
                       </a:r>
@@ -9845,6 +9943,7 @@
                           <a:solidFill>
                             <a:srgbClr val="14323A"/>
                           </a:solidFill>
+                          <a:ea typeface="Microsoft JhengHei"/>
                         </a:rPr>
                         <a:t>983</a:t>
                       </a:r>
@@ -9906,6 +10005,7 @@
                           <a:solidFill>
                             <a:srgbClr val="14323A"/>
                           </a:solidFill>
+                          <a:ea typeface="Microsoft JhengHei"/>
                         </a:rPr>
                         <a:t>1,128</a:t>
                       </a:r>
@@ -9969,6 +10069,7 @@
                           <a:solidFill>
                             <a:srgbClr val="14323A"/>
                           </a:solidFill>
+                          <a:ea typeface="Microsoft JhengHei"/>
                         </a:rPr>
                         <a:t>空間 V（對 1,135）</a:t>
                       </a:r>
@@ -10030,6 +10131,7 @@
                           <a:solidFill>
                             <a:srgbClr val="14323A"/>
                           </a:solidFill>
+                          <a:ea typeface="Microsoft JhengHei"/>
                         </a:rPr>
                         <a:t>−13.4%</a:t>
                       </a:r>
@@ -10091,6 +10193,7 @@
                           <a:solidFill>
                             <a:srgbClr val="14323A"/>
                           </a:solidFill>
+                          <a:ea typeface="Microsoft JhengHei"/>
                         </a:rPr>
                         <a:t>−0.6%</a:t>
                       </a:r>
@@ -10170,6 +10273,10 @@
             <a:prstDash val="solid"/>
           </a:ln>
         </p:spPr>
+        <p:txBody>
+          <a:bodyPr/>
+          <a:p/>
+        </p:txBody>
       </p:sp>
       <p:sp>
         <p:nvSpPr>
@@ -10203,6 +10310,7 @@
                 <a:solidFill>
                   <a:schemeClr val="tx1"/>
                 </a:solidFill>
+                <a:ea typeface="Microsoft JhengHei"/>
               </a:rPr>
               <a:t>輸入與口徑</a:t>
             </a:r>
@@ -10220,6 +10328,7 @@
                 <a:solidFill>
                   <a:schemeClr val="accent5"/>
                 </a:solidFill>
+                <a:ea typeface="Microsoft JhengHei"/>
               </a:rPr>
               <a:t>E＝930,214 千元（1–8 月）、n＝8</a:t>
             </a:r>
@@ -10237,6 +10346,7 @@
                 <a:solidFill>
                   <a:schemeClr val="accent5"/>
                 </a:solidFill>
+                <a:ea typeface="Microsoft JhengHei"/>
               </a:rPr>
               <a:t>H＝合併淨利率；W＝1</a:t>
             </a:r>
@@ -10254,6 +10364,7 @@
                 <a:solidFill>
                   <a:schemeClr val="accent5"/>
                 </a:solidFill>
+                <a:ea typeface="Microsoft JhengHei"/>
               </a:rPr>
               <a:t>I＝2.33925 億；J＝2025 EPS 16.13</a:t>
             </a:r>
@@ -10271,6 +10382,7 @@
                 <a:solidFill>
                   <a:schemeClr val="accent5"/>
                 </a:solidFill>
+                <a:ea typeface="Microsoft JhengHei"/>
               </a:rPr>
               <a:t>base_P／Q＝23.8425／17.391（2026-09-11 錨定）</a:t>
             </a:r>
@@ -10288,6 +10400,7 @@
                 <a:solidFill>
                   <a:schemeClr val="accent5"/>
                 </a:solidFill>
+                <a:ea typeface="Microsoft JhengHei"/>
               </a:rPr>
               <a:t>業外 2.2% &lt; 5%，採帳面 H</a:t>
             </a:r>
@@ -10396,6 +10509,7 @@
                 <a:solidFill>
                   <a:schemeClr val="accent1"/>
                 </a:solidFill>
+                <a:ea typeface="Microsoft JhengHei"/>
               </a:rPr>
               <a:t>同業相對估值：品質第一，估值只略高於中位數</a:t>
             </a:r>
@@ -10448,6 +10562,7 @@
                           <a:solidFill>
                             <a:srgbClr val="FFFFFF"/>
                           </a:solidFill>
+                          <a:ea typeface="Microsoft JhengHei"/>
                         </a:rPr>
                         <a:t>公司</a:t>
                       </a:r>
@@ -10509,6 +10624,7 @@
                           <a:solidFill>
                             <a:srgbClr val="FFFFFF"/>
                           </a:solidFill>
+                          <a:ea typeface="Microsoft JhengHei"/>
                         </a:rPr>
                         <a:t>收盤</a:t>
                       </a:r>
@@ -10570,6 +10686,7 @@
                           <a:solidFill>
                             <a:srgbClr val="FFFFFF"/>
                           </a:solidFill>
+                          <a:ea typeface="Microsoft JhengHei"/>
                         </a:rPr>
                         <a:t>PE（TTM）</a:t>
                       </a:r>
@@ -10631,6 +10748,7 @@
                           <a:solidFill>
                             <a:srgbClr val="FFFFFF"/>
                           </a:solidFill>
+                          <a:ea typeface="Microsoft JhengHei"/>
                         </a:rPr>
                         <a:t>PB</a:t>
                       </a:r>
@@ -10692,6 +10810,7 @@
                           <a:solidFill>
                             <a:srgbClr val="FFFFFF"/>
                           </a:solidFill>
+                          <a:ea typeface="Microsoft JhengHei"/>
                         </a:rPr>
                         <a:t>毛利率</a:t>
                       </a:r>
@@ -10753,6 +10872,7 @@
                           <a:solidFill>
                             <a:srgbClr val="FFFFFF"/>
                           </a:solidFill>
+                          <a:ea typeface="Microsoft JhengHei"/>
                         </a:rPr>
                         <a:t>淨利率</a:t>
                       </a:r>
@@ -10814,6 +10934,7 @@
                           <a:solidFill>
                             <a:srgbClr val="FFFFFF"/>
                           </a:solidFill>
+                          <a:ea typeface="Microsoft JhengHei"/>
                         </a:rPr>
                         <a:t>1–8 月 YoY</a:t>
                       </a:r>
@@ -10877,6 +10998,7 @@
                           <a:solidFill>
                             <a:srgbClr val="14323A"/>
                           </a:solidFill>
+                          <a:ea typeface="Microsoft JhengHei"/>
                         </a:rPr>
                         <a:t>竹陞 6739</a:t>
                       </a:r>
@@ -10938,6 +11060,7 @@
                           <a:solidFill>
                             <a:srgbClr val="14323A"/>
                           </a:solidFill>
+                          <a:ea typeface="Microsoft JhengHei"/>
                         </a:rPr>
                         <a:t>1,135</a:t>
                       </a:r>
@@ -10999,6 +11122,7 @@
                           <a:solidFill>
                             <a:srgbClr val="14323A"/>
                           </a:solidFill>
+                          <a:ea typeface="Microsoft JhengHei"/>
                         </a:rPr>
                         <a:t>47.8</a:t>
                       </a:r>
@@ -11060,6 +11184,7 @@
                           <a:solidFill>
                             <a:srgbClr val="14323A"/>
                           </a:solidFill>
+                          <a:ea typeface="Microsoft JhengHei"/>
                         </a:rPr>
                         <a:t>25.7</a:t>
                       </a:r>
@@ -11121,6 +11246,7 @@
                           <a:solidFill>
                             <a:srgbClr val="14323A"/>
                           </a:solidFill>
+                          <a:ea typeface="Microsoft JhengHei"/>
                         </a:rPr>
                         <a:t>67.5%</a:t>
                       </a:r>
@@ -11182,6 +11308,7 @@
                           <a:solidFill>
                             <a:srgbClr val="14323A"/>
                           </a:solidFill>
+                          <a:ea typeface="Microsoft JhengHei"/>
                         </a:rPr>
                         <a:t>48.2%</a:t>
                       </a:r>
@@ -11243,6 +11370,7 @@
                           <a:solidFill>
                             <a:srgbClr val="14323A"/>
                           </a:solidFill>
+                          <a:ea typeface="Microsoft JhengHei"/>
                         </a:rPr>
                         <a:t>+97.1%</a:t>
                       </a:r>
@@ -11306,6 +11434,7 @@
                           <a:solidFill>
                             <a:srgbClr val="14323A"/>
                           </a:solidFill>
+                          <a:ea typeface="Microsoft JhengHei"/>
                         </a:rPr>
                         <a:t>萬潤 6187</a:t>
                       </a:r>
@@ -11367,6 +11496,7 @@
                           <a:solidFill>
                             <a:srgbClr val="14323A"/>
                           </a:solidFill>
+                          <a:ea typeface="Microsoft JhengHei"/>
                         </a:rPr>
                         <a:t>1,280</a:t>
                       </a:r>
@@ -11428,6 +11558,7 @@
                           <a:solidFill>
                             <a:srgbClr val="14323A"/>
                           </a:solidFill>
+                          <a:ea typeface="Microsoft JhengHei"/>
                         </a:rPr>
                         <a:t>65.3</a:t>
                       </a:r>
@@ -11489,6 +11620,7 @@
                           <a:solidFill>
                             <a:srgbClr val="14323A"/>
                           </a:solidFill>
+                          <a:ea typeface="Microsoft JhengHei"/>
                         </a:rPr>
                         <a:t>14.8</a:t>
                       </a:r>
@@ -11550,6 +11682,7 @@
                           <a:solidFill>
                             <a:srgbClr val="14323A"/>
                           </a:solidFill>
+                          <a:ea typeface="Microsoft JhengHei"/>
                         </a:rPr>
                         <a:t>53.7%</a:t>
                       </a:r>
@@ -11611,6 +11744,7 @@
                           <a:solidFill>
                             <a:srgbClr val="14323A"/>
                           </a:solidFill>
+                          <a:ea typeface="Microsoft JhengHei"/>
                         </a:rPr>
                         <a:t>30.2%</a:t>
                       </a:r>
@@ -11672,6 +11806,7 @@
                           <a:solidFill>
                             <a:srgbClr val="14323A"/>
                           </a:solidFill>
+                          <a:ea typeface="Microsoft JhengHei"/>
                         </a:rPr>
                         <a:t>+51.1%</a:t>
                       </a:r>
@@ -11735,6 +11870,7 @@
                           <a:solidFill>
                             <a:srgbClr val="14323A"/>
                           </a:solidFill>
+                          <a:ea typeface="Microsoft JhengHei"/>
                         </a:rPr>
                         <a:t>弘塑 3131</a:t>
                       </a:r>
@@ -11796,6 +11932,7 @@
                           <a:solidFill>
                             <a:srgbClr val="14323A"/>
                           </a:solidFill>
+                          <a:ea typeface="Microsoft JhengHei"/>
                         </a:rPr>
                         <a:t>2,525</a:t>
                       </a:r>
@@ -11857,6 +11994,7 @@
                           <a:solidFill>
                             <a:srgbClr val="14323A"/>
                           </a:solidFill>
+                          <a:ea typeface="Microsoft JhengHei"/>
                         </a:rPr>
                         <a:t>44.3</a:t>
                       </a:r>
@@ -11918,6 +12056,7 @@
                           <a:solidFill>
                             <a:srgbClr val="14323A"/>
                           </a:solidFill>
+                          <a:ea typeface="Microsoft JhengHei"/>
                         </a:rPr>
                         <a:t>23.4</a:t>
                       </a:r>
@@ -11979,6 +12118,7 @@
                           <a:solidFill>
                             <a:srgbClr val="14323A"/>
                           </a:solidFill>
+                          <a:ea typeface="Microsoft JhengHei"/>
                         </a:rPr>
                         <a:t>36.4%</a:t>
                       </a:r>
@@ -12040,6 +12180,7 @@
                           <a:solidFill>
                             <a:srgbClr val="14323A"/>
                           </a:solidFill>
+                          <a:ea typeface="Microsoft JhengHei"/>
                         </a:rPr>
                         <a:t>23.6%</a:t>
                       </a:r>
@@ -12101,6 +12242,7 @@
                           <a:solidFill>
                             <a:srgbClr val="14323A"/>
                           </a:solidFill>
+                          <a:ea typeface="Microsoft JhengHei"/>
                         </a:rPr>
                         <a:t>+22.9%</a:t>
                       </a:r>
@@ -12164,6 +12306,7 @@
                           <a:solidFill>
                             <a:srgbClr val="14323A"/>
                           </a:solidFill>
+                          <a:ea typeface="Microsoft JhengHei"/>
                         </a:rPr>
                         <a:t>盟立 2464</a:t>
                       </a:r>
@@ -12225,6 +12368,7 @@
                           <a:solidFill>
                             <a:srgbClr val="14323A"/>
                           </a:solidFill>
+                          <a:ea typeface="Microsoft JhengHei"/>
                         </a:rPr>
                         <a:t>196</a:t>
                       </a:r>
@@ -12286,8 +12430,9 @@
                           <a:solidFill>
                             <a:srgbClr val="14323A"/>
                           </a:solidFill>
+                          <a:ea typeface="Microsoft JhengHei"/>
                         </a:rPr>
-                        <a:t>⚫ 478</a:t>
+                        <a:t>478（離群值）</a:t>
                       </a:r>
                       <a:endParaRPr lang="en-US" sz="1100" dirty="0"/>
                     </a:p>
@@ -12347,6 +12492,7 @@
                           <a:solidFill>
                             <a:srgbClr val="14323A"/>
                           </a:solidFill>
+                          <a:ea typeface="Microsoft JhengHei"/>
                         </a:rPr>
                         <a:t>7.1</a:t>
                       </a:r>
@@ -12408,6 +12554,7 @@
                           <a:solidFill>
                             <a:srgbClr val="14323A"/>
                           </a:solidFill>
+                          <a:ea typeface="Microsoft JhengHei"/>
                         </a:rPr>
                         <a:t>20.6%</a:t>
                       </a:r>
@@ -12469,6 +12616,7 @@
                           <a:solidFill>
                             <a:srgbClr val="14323A"/>
                           </a:solidFill>
+                          <a:ea typeface="Microsoft JhengHei"/>
                         </a:rPr>
                         <a:t>3.4%</a:t>
                       </a:r>
@@ -12530,6 +12678,7 @@
                           <a:solidFill>
                             <a:srgbClr val="14323A"/>
                           </a:solidFill>
+                          <a:ea typeface="Microsoft JhengHei"/>
                         </a:rPr>
                         <a:t>+31.4%</a:t>
                       </a:r>
@@ -12593,6 +12742,7 @@
                           <a:solidFill>
                             <a:srgbClr val="14323A"/>
                           </a:solidFill>
+                          <a:ea typeface="Microsoft JhengHei"/>
                         </a:rPr>
                         <a:t>迅得 6438</a:t>
                       </a:r>
@@ -12654,6 +12804,7 @@
                           <a:solidFill>
                             <a:srgbClr val="14323A"/>
                           </a:solidFill>
+                          <a:ea typeface="Microsoft JhengHei"/>
                         </a:rPr>
                         <a:t>164</a:t>
                       </a:r>
@@ -12715,6 +12866,7 @@
                           <a:solidFill>
                             <a:srgbClr val="14323A"/>
                           </a:solidFill>
+                          <a:ea typeface="Microsoft JhengHei"/>
                         </a:rPr>
                         <a:t>28.5</a:t>
                       </a:r>
@@ -12776,6 +12928,7 @@
                           <a:solidFill>
                             <a:srgbClr val="14323A"/>
                           </a:solidFill>
+                          <a:ea typeface="Microsoft JhengHei"/>
                         </a:rPr>
                         <a:t>2.1</a:t>
                       </a:r>
@@ -12837,6 +12990,7 @@
                           <a:solidFill>
                             <a:srgbClr val="14323A"/>
                           </a:solidFill>
+                          <a:ea typeface="Microsoft JhengHei"/>
                         </a:rPr>
                         <a:t>26.1%</a:t>
                       </a:r>
@@ -12898,6 +13052,7 @@
                           <a:solidFill>
                             <a:srgbClr val="14323A"/>
                           </a:solidFill>
+                          <a:ea typeface="Microsoft JhengHei"/>
                         </a:rPr>
                         <a:t>8.5%</a:t>
                       </a:r>
@@ -12959,6 +13114,7 @@
                           <a:solidFill>
                             <a:srgbClr val="14323A"/>
                           </a:solidFill>
+                          <a:ea typeface="Microsoft JhengHei"/>
                         </a:rPr>
                         <a:t>+11.5%</a:t>
                       </a:r>
@@ -13022,6 +13178,7 @@
                           <a:solidFill>
                             <a:srgbClr val="14323A"/>
                           </a:solidFill>
+                          <a:ea typeface="Microsoft JhengHei"/>
                         </a:rPr>
                         <a:t>同業中位數</a:t>
                       </a:r>
@@ -13083,6 +13240,7 @@
                           <a:solidFill>
                             <a:srgbClr val="14323A"/>
                           </a:solidFill>
+                          <a:ea typeface="Microsoft JhengHei"/>
                         </a:rPr>
                         <a:t>—</a:t>
                       </a:r>
@@ -13144,6 +13302,7 @@
                           <a:solidFill>
                             <a:srgbClr val="14323A"/>
                           </a:solidFill>
+                          <a:ea typeface="Microsoft JhengHei"/>
                         </a:rPr>
                         <a:t>44.3</a:t>
                       </a:r>
@@ -13205,6 +13364,7 @@
                           <a:solidFill>
                             <a:srgbClr val="14323A"/>
                           </a:solidFill>
+                          <a:ea typeface="Microsoft JhengHei"/>
                         </a:rPr>
                         <a:t>10.9</a:t>
                       </a:r>
@@ -13266,6 +13426,7 @@
                           <a:solidFill>
                             <a:srgbClr val="14323A"/>
                           </a:solidFill>
+                          <a:ea typeface="Microsoft JhengHei"/>
                         </a:rPr>
                         <a:t>31.3%</a:t>
                       </a:r>
@@ -13327,6 +13488,7 @@
                           <a:solidFill>
                             <a:srgbClr val="14323A"/>
                           </a:solidFill>
+                          <a:ea typeface="Microsoft JhengHei"/>
                         </a:rPr>
                         <a:t>16.1%</a:t>
                       </a:r>
@@ -13388,6 +13550,7 @@
                           <a:solidFill>
                             <a:srgbClr val="14323A"/>
                           </a:solidFill>
+                          <a:ea typeface="Microsoft JhengHei"/>
                         </a:rPr>
                         <a:t>+27.2%</a:t>
                       </a:r>
@@ -13467,6 +13630,10 @@
             <a:prstDash val="solid"/>
           </a:ln>
         </p:spPr>
+        <p:txBody>
+          <a:bodyPr/>
+          <a:p/>
+        </p:txBody>
       </p:sp>
       <p:sp>
         <p:nvSpPr>
@@ -13500,6 +13667,7 @@
                 <a:solidFill>
                   <a:schemeClr val="tx1"/>
                 </a:solidFill>
+                <a:ea typeface="Microsoft JhengHei"/>
               </a:rPr>
               <a:t>相對指標</a:t>
             </a:r>
@@ -13517,6 +13685,7 @@
                 <a:solidFill>
                   <a:schemeClr val="accent5"/>
                 </a:solidFill>
+                <a:ea typeface="Microsoft JhengHei"/>
               </a:rPr>
               <a:t>RelPE 1.08（合理）；前瞻 0.89／0.81</a:t>
             </a:r>
@@ -13534,6 +13703,7 @@
                 <a:solidFill>
                   <a:schemeClr val="accent5"/>
                 </a:solidFill>
+                <a:ea typeface="Microsoft JhengHei"/>
               </a:rPr>
               <a:t>毛利率 +36.2pp；營收成長 +69.9pp</a:t>
             </a:r>
@@ -13567,6 +13737,10 @@
             <a:prstDash val="solid"/>
           </a:ln>
         </p:spPr>
+        <p:txBody>
+          <a:bodyPr/>
+          <a:p/>
+        </p:txBody>
       </p:sp>
       <p:sp>
         <p:nvSpPr>
@@ -13600,6 +13774,7 @@
                 <a:solidFill>
                   <a:schemeClr val="bg1"/>
                 </a:solidFill>
+                <a:ea typeface="Microsoft JhengHei"/>
               </a:rPr>
               <a:t>盈餘品質修正</a:t>
             </a:r>
@@ -13617,6 +13792,7 @@
                 <a:solidFill>
                   <a:schemeClr val="bg1"/>
                 </a:solidFill>
+                <a:ea typeface="Microsoft JhengHei"/>
               </a:rPr>
               <a:t>萬潤業外占稅前 17.3%、弘塑 41.7%（一次性）</a:t>
             </a:r>
@@ -13634,6 +13810,7 @@
                 <a:solidFill>
                   <a:schemeClr val="bg1"/>
                 </a:solidFill>
+                <a:ea typeface="Microsoft JhengHei"/>
               </a:rPr>
               <a:t>同業本業 PE 更高，竹陞相對更便宜</a:t>
             </a:r>
@@ -13742,6 +13919,7 @@
                 <a:solidFill>
                   <a:schemeClr val="accent1"/>
                 </a:solidFill>
+                <a:ea typeface="Microsoft JhengHei"/>
               </a:rPr>
               <a:t>一頁結論：好公司、絕對估值偏滿、相對同業不貴</a:t>
             </a:r>
@@ -13779,7 +13957,7 @@
                   <a:schemeClr val="accent1"/>
                 </a:solidFill>
                 <a:latin typeface="Impact" pitchFamily="34" charset="0"/>
-                <a:ea typeface="Impact" pitchFamily="34" charset="-122"/>
+                <a:ea typeface="Microsoft JhengHei" pitchFamily="34" charset="-122"/>
                 <a:cs typeface="Impact" pitchFamily="34" charset="-120"/>
               </a:rPr>
               <a:t>+97%</a:t>
@@ -13817,6 +13995,7 @@
                 <a:solidFill>
                   <a:schemeClr val="accent5"/>
                 </a:solidFill>
+                <a:ea typeface="Microsoft JhengHei"/>
               </a:rPr>
               <a:t>2026 年 1–8 月營收 YoY（9.30 億元）</a:t>
             </a:r>
@@ -13854,7 +14033,7 @@
                   <a:schemeClr val="accent1"/>
                 </a:solidFill>
                 <a:latin typeface="Impact" pitchFamily="34" charset="0"/>
-                <a:ea typeface="Impact" pitchFamily="34" charset="-122"/>
+                <a:ea typeface="Microsoft JhengHei" pitchFamily="34" charset="-122"/>
                 <a:cs typeface="Impact" pitchFamily="34" charset="-120"/>
               </a:rPr>
               <a:t>58%</a:t>
@@ -13892,6 +14071,7 @@
                 <a:solidFill>
                   <a:schemeClr val="accent5"/>
                 </a:solidFill>
+                <a:ea typeface="Microsoft JhengHei"/>
               </a:rPr>
               <a:t>2026Q2 營益率；毛利率 66.8%</a:t>
             </a:r>
@@ -13929,7 +14109,7 @@
                   <a:schemeClr val="accent4"/>
                 </a:solidFill>
                 <a:latin typeface="Impact" pitchFamily="34" charset="0"/>
-                <a:ea typeface="Impact" pitchFamily="34" charset="-122"/>
+                <a:ea typeface="Microsoft JhengHei" pitchFamily="34" charset="-122"/>
                 <a:cs typeface="Impact" pitchFamily="34" charset="-120"/>
               </a:rPr>
               <a:t>983</a:t>
@@ -13967,6 +14147,7 @@
                 <a:solidFill>
                   <a:schemeClr val="accent5"/>
                 </a:solidFill>
+                <a:ea typeface="Microsoft JhengHei"/>
               </a:rPr>
               <a:t>Kevin 情境 A 目標價（−13.4%）</a:t>
             </a:r>
@@ -14004,7 +14185,7 @@
                   <a:schemeClr val="accent1"/>
                 </a:solidFill>
                 <a:latin typeface="Impact" pitchFamily="34" charset="0"/>
-                <a:ea typeface="Impact" pitchFamily="34" charset="-122"/>
+                <a:ea typeface="Microsoft JhengHei" pitchFamily="34" charset="-122"/>
                 <a:cs typeface="Impact" pitchFamily="34" charset="-120"/>
               </a:rPr>
               <a:t>1.08x</a:t>
@@ -14042,6 +14223,7 @@
                 <a:solidFill>
                   <a:schemeClr val="accent5"/>
                 </a:solidFill>
+                <a:ea typeface="Microsoft JhengHei"/>
               </a:rPr>
               <a:t>PE 相對同業中位數（毛利率 +36pp）</a:t>
             </a:r>
@@ -14075,6 +14257,10 @@
             <a:prstDash val="solid"/>
           </a:ln>
         </p:spPr>
+        <p:txBody>
+          <a:bodyPr/>
+          <a:p/>
+        </p:txBody>
       </p:sp>
       <p:sp>
         <p:nvSpPr>
@@ -14108,6 +14294,7 @@
                 <a:solidFill>
                   <a:schemeClr val="tx1"/>
                 </a:solidFill>
+                <a:ea typeface="Microsoft JhengHei"/>
               </a:rPr>
               <a:t>多方</a:t>
             </a:r>
@@ -14125,6 +14312,7 @@
                 <a:solidFill>
                   <a:schemeClr val="accent5"/>
                 </a:solidFill>
+                <a:ea typeface="Microsoft JhengHei"/>
               </a:rPr>
               <a:t>跨 82 品牌、512 機型整合，客戶標配、轉換成本高</a:t>
             </a:r>
@@ -14142,6 +14330,7 @@
                 <a:solidFill>
                   <a:schemeClr val="accent5"/>
                 </a:solidFill>
+                <a:ea typeface="Microsoft JhengHei"/>
               </a:rPr>
               <a:t>先進封裝 48%、記憶體 27%、晶圓代工 23%，三條擴產線同時受惠</a:t>
             </a:r>
@@ -14159,6 +14348,7 @@
                 <a:solidFill>
                   <a:schemeClr val="accent5"/>
                 </a:solidFill>
+                <a:ea typeface="Microsoft JhengHei"/>
               </a:rPr>
               <a:t>在手訂單能見度至 2027Q2；全年指引 15.3–16.1 億</a:t>
             </a:r>
@@ -14176,6 +14366,7 @@
                 <a:solidFill>
                   <a:schemeClr val="accent5"/>
                 </a:solidFill>
+                <a:ea typeface="Microsoft JhengHei"/>
               </a:rPr>
               <a:t>GoVision 2025 年營收 +353%，第二成長曲線成形</a:t>
             </a:r>
@@ -14209,6 +14400,10 @@
             <a:prstDash val="solid"/>
           </a:ln>
         </p:spPr>
+        <p:txBody>
+          <a:bodyPr/>
+          <a:p/>
+        </p:txBody>
       </p:sp>
       <p:sp>
         <p:nvSpPr>
@@ -14242,6 +14437,7 @@
                 <a:solidFill>
                   <a:schemeClr val="bg1"/>
                 </a:solidFill>
+                <a:ea typeface="Microsoft JhengHei"/>
               </a:rPr>
               <a:t>空方與判讀</a:t>
             </a:r>
@@ -14259,6 +14455,7 @@
                 <a:solidFill>
                   <a:schemeClr val="bg1"/>
                 </a:solidFill>
+                <a:ea typeface="Microsoft JhengHei"/>
               </a:rPr>
               <a:t>前三大客戶占 96%，H 客戶 67%</a:t>
             </a:r>
@@ -14276,6 +14473,7 @@
                 <a:solidFill>
                   <a:schemeClr val="bg1"/>
                 </a:solidFill>
+                <a:ea typeface="Microsoft JhengHei"/>
               </a:rPr>
               <a:t>設備原廠與晶圓廠自研是長期替代風險</a:t>
             </a:r>
@@ -14293,6 +14491,7 @@
                 <a:solidFill>
                   <a:schemeClr val="bg1"/>
                 </a:solidFill>
+                <a:ea typeface="Microsoft JhengHei"/>
               </a:rPr>
               <a:t>情境 B 1,128（−0.6%）：現價已反映近月動能</a:t>
             </a:r>
@@ -14310,6 +14509,7 @@
                 <a:solidFill>
                   <a:schemeClr val="bg1"/>
                 </a:solidFill>
+                <a:ea typeface="Microsoft JhengHei"/>
               </a:rPr>
               <a:t>判讀：中性偏多，回檔至 980–1,020 元風險報酬較佳</a:t>
             </a:r>
@@ -14418,6 +14618,7 @@
                 <a:solidFill>
                   <a:schemeClr val="bg1"/>
                 </a:solidFill>
+                <a:ea typeface="Microsoft JhengHei"/>
               </a:rPr>
               <a:t>風險與追蹤</a:t>
             </a:r>
@@ -14456,6 +14657,7 @@
                 <a:solidFill>
                   <a:schemeClr val="accent3"/>
                 </a:solidFill>
+                <a:ea typeface="Microsoft JhengHei"/>
               </a:rPr>
               <a:t>客戶集中、替代風險、估值波動</a:t>
             </a:r>
@@ -14519,6 +14721,7 @@
                 <a:solidFill>
                   <a:schemeClr val="accent1"/>
                 </a:solidFill>
+                <a:ea typeface="Microsoft JhengHei"/>
               </a:rPr>
               <a:t>風險矩陣</a:t>
             </a:r>
@@ -14568,6 +14771,7 @@
                           <a:solidFill>
                             <a:srgbClr val="FFFFFF"/>
                           </a:solidFill>
+                          <a:ea typeface="Microsoft JhengHei"/>
                         </a:rPr>
                         <a:t>風險</a:t>
                       </a:r>
@@ -14629,6 +14833,7 @@
                           <a:solidFill>
                             <a:srgbClr val="FFFFFF"/>
                           </a:solidFill>
+                          <a:ea typeface="Microsoft JhengHei"/>
                         </a:rPr>
                         <a:t>說明</a:t>
                       </a:r>
@@ -14690,6 +14895,7 @@
                           <a:solidFill>
                             <a:srgbClr val="FFFFFF"/>
                           </a:solidFill>
+                          <a:ea typeface="Microsoft JhengHei"/>
                         </a:rPr>
                         <a:t>嚴重度</a:t>
                       </a:r>
@@ -14751,6 +14957,7 @@
                           <a:solidFill>
                             <a:srgbClr val="FFFFFF"/>
                           </a:solidFill>
+                          <a:ea typeface="Microsoft JhengHei"/>
                         </a:rPr>
                         <a:t>追蹤指標</a:t>
                       </a:r>
@@ -14814,6 +15021,7 @@
                           <a:solidFill>
                             <a:srgbClr val="14323A"/>
                           </a:solidFill>
+                          <a:ea typeface="Microsoft JhengHei"/>
                         </a:rPr>
                         <a:t>客戶集中</a:t>
                       </a:r>
@@ -14875,6 +15083,7 @@
                           <a:solidFill>
                             <a:srgbClr val="14323A"/>
                           </a:solidFill>
+                          <a:ea typeface="Microsoft JhengHei"/>
                         </a:rPr>
                         <a:t>H 客戶 67%、前三大 96%</a:t>
                       </a:r>
@@ -14936,6 +15145,7 @@
                           <a:solidFill>
                             <a:srgbClr val="14323A"/>
                           </a:solidFill>
+                          <a:ea typeface="Microsoft JhengHei"/>
                         </a:rPr>
                         <a:t>高</a:t>
                       </a:r>
@@ -14997,6 +15207,7 @@
                           <a:solidFill>
                             <a:srgbClr val="14323A"/>
                           </a:solidFill>
+                          <a:ea typeface="Microsoft JhengHei"/>
                         </a:rPr>
                         <a:t>年報主要客戶、海外廠導入</a:t>
                       </a:r>
@@ -15060,6 +15271,7 @@
                           <a:solidFill>
                             <a:srgbClr val="14323A"/>
                           </a:solidFill>
+                          <a:ea typeface="Microsoft JhengHei"/>
                         </a:rPr>
                         <a:t>估值與流動性</a:t>
                       </a:r>
@@ -15121,6 +15333,7 @@
                           <a:solidFill>
                             <a:srgbClr val="14323A"/>
                           </a:solidFill>
+                          <a:ea typeface="Microsoft JhengHei"/>
                         </a:rPr>
                         <a:t>股本 2.34 億；4 月 1,760 → 7 月 764（−56.6%）</a:t>
                       </a:r>
@@ -15182,6 +15395,7 @@
                           <a:solidFill>
                             <a:srgbClr val="14323A"/>
                           </a:solidFill>
+                          <a:ea typeface="Microsoft JhengHei"/>
                         </a:rPr>
                         <a:t>高</a:t>
                       </a:r>
@@ -15243,6 +15457,7 @@
                           <a:solidFill>
                             <a:srgbClr val="14323A"/>
                           </a:solidFill>
+                          <a:ea typeface="Microsoft JhengHei"/>
                         </a:rPr>
                         <a:t>融資使用率、法人買賣超</a:t>
                       </a:r>
@@ -15306,6 +15521,7 @@
                           <a:solidFill>
                             <a:srgbClr val="14323A"/>
                           </a:solidFill>
+                          <a:ea typeface="Microsoft JhengHei"/>
                         </a:rPr>
                         <a:t>原廠／客戶替代</a:t>
                       </a:r>
@@ -15367,6 +15583,7 @@
                           <a:solidFill>
                             <a:srgbClr val="14323A"/>
                           </a:solidFill>
+                          <a:ea typeface="Microsoft JhengHei"/>
                         </a:rPr>
                         <a:t>設備商內建、晶圓廠自研</a:t>
                       </a:r>
@@ -15428,6 +15645,7 @@
                           <a:solidFill>
                             <a:srgbClr val="14323A"/>
                           </a:solidFill>
+                          <a:ea typeface="Microsoft JhengHei"/>
                         </a:rPr>
                         <a:t>中</a:t>
                       </a:r>
@@ -15489,6 +15707,7 @@
                           <a:solidFill>
                             <a:srgbClr val="14323A"/>
                           </a:solidFill>
+                          <a:ea typeface="Microsoft JhengHei"/>
                         </a:rPr>
                         <a:t>新產線標配率、相容機型數</a:t>
                       </a:r>
@@ -15552,6 +15771,7 @@
                           <a:solidFill>
                             <a:srgbClr val="14323A"/>
                           </a:solidFill>
+                          <a:ea typeface="Microsoft JhengHei"/>
                         </a:rPr>
                         <a:t>資本支出循環</a:t>
                       </a:r>
@@ -15613,6 +15833,7 @@
                           <a:solidFill>
                             <a:srgbClr val="14323A"/>
                           </a:solidFill>
+                          <a:ea typeface="Microsoft JhengHei"/>
                         </a:rPr>
                         <a:t>記憶體、先進封裝擴產放緩</a:t>
                       </a:r>
@@ -15674,6 +15895,7 @@
                           <a:solidFill>
                             <a:srgbClr val="14323A"/>
                           </a:solidFill>
+                          <a:ea typeface="Microsoft JhengHei"/>
                         </a:rPr>
                         <a:t>中</a:t>
                       </a:r>
@@ -15735,6 +15957,7 @@
                           <a:solidFill>
                             <a:srgbClr val="14323A"/>
                           </a:solidFill>
+                          <a:ea typeface="Microsoft JhengHei"/>
                         </a:rPr>
                         <a:t>客戶 capex、在手訂單</a:t>
                       </a:r>
@@ -15798,6 +16021,7 @@
                           <a:solidFill>
                             <a:srgbClr val="14323A"/>
                           </a:solidFill>
+                          <a:ea typeface="Microsoft JhengHei"/>
                         </a:rPr>
                         <a:t>毛利率與費用</a:t>
                       </a:r>
@@ -15859,6 +16083,7 @@
                           <a:solidFill>
                             <a:srgbClr val="14323A"/>
                           </a:solidFill>
+                          <a:ea typeface="Microsoft JhengHei"/>
                         </a:rPr>
                         <a:t>新總部折舊、擴編研發</a:t>
                       </a:r>
@@ -15920,6 +16145,7 @@
                           <a:solidFill>
                             <a:srgbClr val="14323A"/>
                           </a:solidFill>
+                          <a:ea typeface="Microsoft JhengHei"/>
                         </a:rPr>
                         <a:t>中</a:t>
                       </a:r>
@@ -15981,6 +16207,7 @@
                           <a:solidFill>
                             <a:srgbClr val="14323A"/>
                           </a:solidFill>
+                          <a:ea typeface="Microsoft JhengHei"/>
                         </a:rPr>
                         <a:t>Q3 毛利率是否 67–69%</a:t>
                       </a:r>
@@ -16044,6 +16271,7 @@
                           <a:solidFill>
                             <a:srgbClr val="14323A"/>
                           </a:solidFill>
+                          <a:ea typeface="Microsoft JhengHei"/>
                         </a:rPr>
                         <a:t>關係人交易</a:t>
                       </a:r>
@@ -16105,6 +16333,7 @@
                           <a:solidFill>
                             <a:srgbClr val="14323A"/>
                           </a:solidFill>
+                          <a:ea typeface="Microsoft JhengHei"/>
                         </a:rPr>
                         <a:t>向竹駿購廠 3.40 億</a:t>
                       </a:r>
@@ -16166,6 +16395,7 @@
                           <a:solidFill>
                             <a:srgbClr val="14323A"/>
                           </a:solidFill>
+                          <a:ea typeface="Microsoft JhengHei"/>
                         </a:rPr>
                         <a:t>低</a:t>
                       </a:r>
@@ -16227,6 +16457,7 @@
                           <a:solidFill>
                             <a:srgbClr val="14323A"/>
                           </a:solidFill>
+                          <a:ea typeface="Microsoft JhengHei"/>
                         </a:rPr>
                         <a:t>廠房用途與後續交易</a:t>
                       </a:r>
@@ -16381,6 +16612,7 @@
                 <a:solidFill>
                   <a:schemeClr val="accent1"/>
                 </a:solidFill>
+                <a:ea typeface="Microsoft JhengHei"/>
               </a:rPr>
               <a:t>催化劑時間軸</a:t>
             </a:r>
@@ -16412,6 +16644,10 @@
             <a:prstDash val="solid"/>
           </a:ln>
         </p:spPr>
+        <p:txBody>
+          <a:bodyPr/>
+          <a:p/>
+        </p:txBody>
       </p:sp>
       <p:sp>
         <p:nvSpPr>
@@ -16435,6 +16671,10 @@
             <a:prstDash val="solid"/>
           </a:ln>
         </p:spPr>
+        <p:txBody>
+          <a:bodyPr/>
+          <a:p/>
+        </p:txBody>
       </p:sp>
       <p:sp>
         <p:nvSpPr>
@@ -16462,6 +16702,10 @@
             <a:prstDash val="solid"/>
           </a:ln>
         </p:spPr>
+        <p:txBody>
+          <a:bodyPr/>
+          <a:p/>
+        </p:txBody>
       </p:sp>
       <p:sp>
         <p:nvSpPr>
@@ -16495,6 +16739,7 @@
                 <a:solidFill>
                   <a:schemeClr val="tx1"/>
                 </a:solidFill>
+                <a:ea typeface="Microsoft JhengHei"/>
               </a:rPr>
               <a:t>10/10 前</a:t>
             </a:r>
@@ -16512,6 +16757,7 @@
                 <a:solidFill>
                   <a:schemeClr val="accent5"/>
                 </a:solidFill>
+                <a:ea typeface="Microsoft JhengHei"/>
               </a:rPr>
               <a:t>9 月營收</a:t>
             </a:r>
@@ -16529,6 +16775,7 @@
                 <a:solidFill>
                   <a:schemeClr val="accent5"/>
                 </a:solidFill>
+                <a:ea typeface="Microsoft JhengHei"/>
               </a:rPr>
               <a:t>≥ 1.49 億達指引</a:t>
             </a:r>
@@ -16560,6 +16807,10 @@
             <a:prstDash val="solid"/>
           </a:ln>
         </p:spPr>
+        <p:txBody>
+          <a:bodyPr/>
+          <a:p/>
+        </p:txBody>
       </p:sp>
       <p:sp>
         <p:nvSpPr>
@@ -16583,6 +16834,10 @@
             <a:prstDash val="solid"/>
           </a:ln>
         </p:spPr>
+        <p:txBody>
+          <a:bodyPr/>
+          <a:p/>
+        </p:txBody>
       </p:sp>
       <p:sp>
         <p:nvSpPr>
@@ -16610,6 +16865,10 @@
             <a:prstDash val="solid"/>
           </a:ln>
         </p:spPr>
+        <p:txBody>
+          <a:bodyPr/>
+          <a:p/>
+        </p:txBody>
       </p:sp>
       <p:sp>
         <p:nvSpPr>
@@ -16643,6 +16902,7 @@
                 <a:solidFill>
                   <a:schemeClr val="tx1"/>
                 </a:solidFill>
+                <a:ea typeface="Microsoft JhengHei"/>
               </a:rPr>
               <a:t>11 月中</a:t>
             </a:r>
@@ -16660,6 +16920,7 @@
                 <a:solidFill>
                   <a:schemeClr val="accent5"/>
                 </a:solidFill>
+                <a:ea typeface="Microsoft JhengHei"/>
               </a:rPr>
               <a:t>Q3 財報</a:t>
             </a:r>
@@ -16677,6 +16938,7 @@
                 <a:solidFill>
                   <a:schemeClr val="accent5"/>
                 </a:solidFill>
+                <a:ea typeface="Microsoft JhengHei"/>
               </a:rPr>
               <a:t>營益率 58–60%</a:t>
             </a:r>
@@ -16708,6 +16970,10 @@
             <a:prstDash val="solid"/>
           </a:ln>
         </p:spPr>
+        <p:txBody>
+          <a:bodyPr/>
+          <a:p/>
+        </p:txBody>
       </p:sp>
       <p:sp>
         <p:nvSpPr>
@@ -16731,6 +16997,10 @@
             <a:prstDash val="solid"/>
           </a:ln>
         </p:spPr>
+        <p:txBody>
+          <a:bodyPr/>
+          <a:p/>
+        </p:txBody>
       </p:sp>
       <p:sp>
         <p:nvSpPr>
@@ -16758,6 +17028,10 @@
             <a:prstDash val="solid"/>
           </a:ln>
         </p:spPr>
+        <p:txBody>
+          <a:bodyPr/>
+          <a:p/>
+        </p:txBody>
       </p:sp>
       <p:sp>
         <p:nvSpPr>
@@ -16791,6 +17065,7 @@
                 <a:solidFill>
                   <a:schemeClr val="tx1"/>
                 </a:solidFill>
+                <a:ea typeface="Microsoft JhengHei"/>
               </a:rPr>
               <a:t>2026Q4</a:t>
             </a:r>
@@ -16808,6 +17083,7 @@
                 <a:solidFill>
                   <a:schemeClr val="accent5"/>
                 </a:solidFill>
+                <a:ea typeface="Microsoft JhengHei"/>
               </a:rPr>
               <a:t>新竹總部、法說</a:t>
             </a:r>
@@ -16825,6 +17101,7 @@
                 <a:solidFill>
                   <a:schemeClr val="accent5"/>
                 </a:solidFill>
+                <a:ea typeface="Microsoft JhengHei"/>
               </a:rPr>
               <a:t>2027 成長指引</a:t>
             </a:r>
@@ -16856,6 +17133,10 @@
             <a:prstDash val="solid"/>
           </a:ln>
         </p:spPr>
+        <p:txBody>
+          <a:bodyPr/>
+          <a:p/>
+        </p:txBody>
       </p:sp>
       <p:sp>
         <p:nvSpPr>
@@ -16883,6 +17164,10 @@
             <a:prstDash val="solid"/>
           </a:ln>
         </p:spPr>
+        <p:txBody>
+          <a:bodyPr/>
+          <a:p/>
+        </p:txBody>
       </p:sp>
       <p:sp>
         <p:nvSpPr>
@@ -16916,6 +17201,7 @@
                 <a:solidFill>
                   <a:schemeClr val="tx1"/>
                 </a:solidFill>
+                <a:ea typeface="Microsoft JhengHei"/>
               </a:rPr>
               <a:t>2027</a:t>
             </a:r>
@@ -16933,6 +17219,7 @@
                 <a:solidFill>
                   <a:schemeClr val="accent5"/>
                 </a:solidFill>
+                <a:ea typeface="Microsoft JhengHei"/>
               </a:rPr>
               <a:t>海外廠導入</a:t>
             </a:r>
@@ -16950,6 +17237,7 @@
                 <a:solidFill>
                   <a:schemeClr val="accent5"/>
                 </a:solidFill>
+                <a:ea typeface="Microsoft JhengHei"/>
               </a:rPr>
               <a:t>非台灣營收占比</a:t>
             </a:r>
@@ -16983,6 +17271,10 @@
             <a:prstDash val="solid"/>
           </a:ln>
         </p:spPr>
+        <p:txBody>
+          <a:bodyPr/>
+          <a:p/>
+        </p:txBody>
       </p:sp>
       <p:sp>
         <p:nvSpPr>
@@ -17016,6 +17308,7 @@
                 <a:solidFill>
                   <a:schemeClr val="tx1"/>
                 </a:solidFill>
+                <a:ea typeface="Microsoft JhengHei"/>
               </a:rPr>
               <a:t>資料缺口（待本機 plugin 補齊）</a:t>
             </a:r>
@@ -17033,6 +17326,7 @@
                 <a:solidFill>
                   <a:schemeClr val="accent5"/>
                 </a:solidFill>
+                <a:ea typeface="Microsoft JhengHei"/>
               </a:rPr>
               <a:t>法說會簡報原件、2026Q1／2025Q1 季報、2024 年報、股東會議事手冊；年報 p.77–101 產銷與原料章節</a:t>
             </a:r>
@@ -17141,6 +17435,7 @@
                 <a:solidFill>
                   <a:schemeClr val="bg1"/>
                 </a:solidFill>
+                <a:ea typeface="Microsoft JhengHei"/>
               </a:rPr>
               <a:t>結論</a:t>
             </a:r>
@@ -17179,6 +17474,7 @@
                 <a:solidFill>
                   <a:schemeClr val="bg1"/>
                 </a:solidFill>
+                <a:ea typeface="Microsoft JhengHei"/>
               </a:rPr>
               <a:t>竹陞是半導體擴產的「後裝智慧化」標配廠，2026 年成長已被定價；下一步看 2027 年成長能否維持 30% 以上與客戶分散。本簡報為 Kevin 個人模型試算與研究整理，非投資建議。</a:t>
             </a:r>
@@ -17242,6 +17538,7 @@
                 <a:solidFill>
                   <a:schemeClr val="bg1"/>
                 </a:solidFill>
+                <a:ea typeface="Microsoft JhengHei"/>
               </a:rPr>
               <a:t>公司與產品</a:t>
             </a:r>
@@ -17280,6 +17577,7 @@
                 <a:solidFill>
                   <a:schemeClr val="accent3"/>
                 </a:solidFill>
+                <a:ea typeface="Microsoft JhengHei"/>
               </a:rPr>
               <a:t>三條產品線、一個邊緣運算平台、跨品牌機台整合</a:t>
             </a:r>
@@ -17343,6 +17641,7 @@
                 <a:solidFill>
                   <a:schemeClr val="accent1"/>
                 </a:solidFill>
+                <a:ea typeface="Microsoft JhengHei"/>
               </a:rPr>
               <a:t>公司快照</a:t>
             </a:r>
@@ -17376,6 +17675,10 @@
             <a:prstDash val="solid"/>
           </a:ln>
         </p:spPr>
+        <p:txBody>
+          <a:bodyPr/>
+          <a:p/>
+        </p:txBody>
       </p:sp>
       <p:sp>
         <p:nvSpPr>
@@ -17409,6 +17712,7 @@
                 <a:solidFill>
                   <a:schemeClr val="tx1"/>
                 </a:solidFill>
+                <a:ea typeface="Microsoft JhengHei"/>
               </a:rPr>
               <a:t>基本資料</a:t>
             </a:r>
@@ -17426,6 +17730,7 @@
                 <a:solidFill>
                   <a:schemeClr val="accent5"/>
                 </a:solidFill>
+                <a:ea typeface="Microsoft JhengHei"/>
               </a:rPr>
               <a:t>2017 成立；2024/09/02 上櫃</a:t>
             </a:r>
@@ -17443,6 +17748,7 @@
                 <a:solidFill>
                   <a:schemeClr val="accent5"/>
                 </a:solidFill>
+                <a:ea typeface="Microsoft JhengHei"/>
               </a:rPr>
               <a:t>董事長兼總經理 方泰又（前聯電黃光技術委員會召集人）</a:t>
             </a:r>
@@ -17476,6 +17782,10 @@
             <a:prstDash val="solid"/>
           </a:ln>
         </p:spPr>
+        <p:txBody>
+          <a:bodyPr/>
+          <a:p/>
+        </p:txBody>
       </p:sp>
       <p:sp>
         <p:nvSpPr>
@@ -17509,6 +17819,7 @@
                 <a:solidFill>
                   <a:schemeClr val="tx1"/>
                 </a:solidFill>
+                <a:ea typeface="Microsoft JhengHei"/>
               </a:rPr>
               <a:t>股本與市值</a:t>
             </a:r>
@@ -17526,6 +17837,7 @@
                 <a:solidFill>
                   <a:schemeClr val="accent5"/>
                 </a:solidFill>
+                <a:ea typeface="Microsoft JhengHei"/>
               </a:rPr>
               <a:t>實收股本 2.339 億元（23.39 百萬股）</a:t>
             </a:r>
@@ -17543,6 +17855,7 @@
                 <a:solidFill>
                   <a:schemeClr val="accent5"/>
                 </a:solidFill>
+                <a:ea typeface="Microsoft JhengHei"/>
               </a:rPr>
               <a:t>市值約 265 億元（1,135 元）</a:t>
             </a:r>
@@ -17576,6 +17889,10 @@
             <a:prstDash val="solid"/>
           </a:ln>
         </p:spPr>
+        <p:txBody>
+          <a:bodyPr/>
+          <a:p/>
+        </p:txBody>
       </p:sp>
       <p:sp>
         <p:nvSpPr>
@@ -17609,6 +17926,7 @@
                 <a:solidFill>
                   <a:schemeClr val="tx1"/>
                 </a:solidFill>
+                <a:ea typeface="Microsoft JhengHei"/>
               </a:rPr>
               <a:t>獲利（2025）</a:t>
             </a:r>
@@ -17626,6 +17944,7 @@
                 <a:solidFill>
                   <a:schemeClr val="accent5"/>
                 </a:solidFill>
+                <a:ea typeface="Microsoft JhengHei"/>
               </a:rPr>
               <a:t>營收 8.06 億（+96.7%）</a:t>
             </a:r>
@@ -17643,6 +17962,7 @@
                 <a:solidFill>
                   <a:schemeClr val="accent5"/>
                 </a:solidFill>
+                <a:ea typeface="Microsoft JhengHei"/>
               </a:rPr>
               <a:t>EPS 16.13 元；現金股利 13 元</a:t>
             </a:r>
@@ -17676,6 +17996,10 @@
             <a:prstDash val="solid"/>
           </a:ln>
         </p:spPr>
+        <p:txBody>
+          <a:bodyPr/>
+          <a:p/>
+        </p:txBody>
       </p:sp>
       <p:sp>
         <p:nvSpPr>
@@ -17709,6 +18033,7 @@
                 <a:solidFill>
                   <a:schemeClr val="tx1"/>
                 </a:solidFill>
+                <a:ea typeface="Microsoft JhengHei"/>
               </a:rPr>
               <a:t>客戶結構（2025）</a:t>
             </a:r>
@@ -17726,6 +18051,7 @@
                 <a:solidFill>
                   <a:schemeClr val="accent5"/>
                 </a:solidFill>
+                <a:ea typeface="Microsoft JhengHei"/>
               </a:rPr>
               <a:t>H 客戶 67%、G 18%、I 11%</a:t>
             </a:r>
@@ -17743,6 +18069,7 @@
                 <a:solidFill>
                   <a:schemeClr val="accent5"/>
                 </a:solidFill>
+                <a:ea typeface="Microsoft JhengHei"/>
               </a:rPr>
               <a:t>前三大合計 96%</a:t>
             </a:r>
@@ -17776,6 +18103,10 @@
             <a:prstDash val="solid"/>
           </a:ln>
         </p:spPr>
+        <p:txBody>
+          <a:bodyPr/>
+          <a:p/>
+        </p:txBody>
       </p:sp>
       <p:sp>
         <p:nvSpPr>
@@ -17809,6 +18140,7 @@
                 <a:solidFill>
                   <a:schemeClr val="tx1"/>
                 </a:solidFill>
+                <a:ea typeface="Microsoft JhengHei"/>
               </a:rPr>
               <a:t>地區（2025）</a:t>
             </a:r>
@@ -17826,6 +18158,7 @@
                 <a:solidFill>
                   <a:schemeClr val="accent5"/>
                 </a:solidFill>
+                <a:ea typeface="Microsoft JhengHei"/>
               </a:rPr>
               <a:t>台灣 86%、新加坡 11%</a:t>
             </a:r>
@@ -17843,6 +18176,7 @@
                 <a:solidFill>
                   <a:schemeClr val="accent5"/>
                 </a:solidFill>
+                <a:ea typeface="Microsoft JhengHei"/>
               </a:rPr>
               <a:t>中國 1%、其他 3%</a:t>
             </a:r>
@@ -17876,6 +18210,10 @@
             <a:prstDash val="solid"/>
           </a:ln>
         </p:spPr>
+        <p:txBody>
+          <a:bodyPr/>
+          <a:p/>
+        </p:txBody>
       </p:sp>
       <p:sp>
         <p:nvSpPr>
@@ -17909,6 +18247,7 @@
                 <a:solidFill>
                   <a:schemeClr val="tx1"/>
                 </a:solidFill>
+                <a:ea typeface="Microsoft JhengHei"/>
               </a:rPr>
               <a:t>資產負債（2026/6/30）</a:t>
             </a:r>
@@ -17926,6 +18265,7 @@
                 <a:solidFill>
                   <a:schemeClr val="accent5"/>
                 </a:solidFill>
+                <a:ea typeface="Microsoft JhengHei"/>
               </a:rPr>
               <a:t>總資產 16.8 億、負債 6.5 億</a:t>
             </a:r>
@@ -17943,6 +18283,7 @@
                 <a:solidFill>
                   <a:schemeClr val="accent5"/>
                 </a:solidFill>
+                <a:ea typeface="Microsoft JhengHei"/>
               </a:rPr>
               <a:t>無銀行借款；淨現金</a:t>
             </a:r>
@@ -17976,6 +18317,10 @@
             <a:prstDash val="solid"/>
           </a:ln>
         </p:spPr>
+        <p:txBody>
+          <a:bodyPr/>
+          <a:p/>
+        </p:txBody>
       </p:sp>
       <p:sp>
         <p:nvSpPr>
@@ -18009,6 +18354,7 @@
                 <a:solidFill>
                   <a:schemeClr val="tx1"/>
                 </a:solidFill>
+                <a:ea typeface="Microsoft JhengHei"/>
               </a:rPr>
               <a:t>轉投資與治理</a:t>
             </a:r>
@@ -18026,6 +18372,7 @@
                 <a:solidFill>
                   <a:schemeClr val="accent5"/>
                 </a:solidFill>
+                <a:ea typeface="Microsoft JhengHei"/>
               </a:rPr>
               <a:t>竹阩智能數據（合肥）2025/12 清算；美國 G2 持股 50%（權益法，經營權由合資方指派）</a:t>
             </a:r>
@@ -18043,6 +18390,7 @@
                 <a:solidFill>
                   <a:schemeClr val="accent5"/>
                 </a:solidFill>
+                <a:ea typeface="Microsoft JhengHei"/>
               </a:rPr>
               <a:t>2025 年向關係人竹駿科技購廠 3.40 億元（董事長任竹駿董事長），需追蹤用途</a:t>
             </a:r>
@@ -18151,6 +18499,7 @@
                 <a:solidFill>
                   <a:schemeClr val="accent1"/>
                 </a:solidFill>
+                <a:ea typeface="Microsoft JhengHei"/>
               </a:rPr>
               <a:t>產品線營收：GoVision 一年從 14% 跳到 32%</a:t>
             </a:r>
@@ -18200,6 +18549,10 @@
             <a:prstDash val="solid"/>
           </a:ln>
         </p:spPr>
+        <p:txBody>
+          <a:bodyPr/>
+          <a:p/>
+        </p:txBody>
       </p:sp>
       <p:sp>
         <p:nvSpPr>
@@ -18233,6 +18586,7 @@
                 <a:solidFill>
                   <a:schemeClr val="tx1"/>
                 </a:solidFill>
+                <a:ea typeface="Microsoft JhengHei"/>
               </a:rPr>
               <a:t>解讀</a:t>
             </a:r>
@@ -18250,6 +18604,7 @@
                 <a:solidFill>
                   <a:schemeClr val="accent5"/>
                 </a:solidFill>
+                <a:ea typeface="Microsoft JhengHei"/>
               </a:rPr>
               <a:t>GoVision +353%：AI 視覺／聽覺／嗅覺由光阻塗佈擴展到更多站點</a:t>
             </a:r>
@@ -18267,6 +18622,7 @@
                 <a:solidFill>
                   <a:schemeClr val="accent5"/>
                 </a:solidFill>
+                <a:ea typeface="Microsoft JhengHei"/>
               </a:rPr>
               <a:t>AI 操作 +52%、IoT +60%：既有產品隨擴產同步成長</a:t>
             </a:r>
@@ -18284,6 +18640,7 @@
                 <a:solidFill>
                   <a:schemeClr val="accent5"/>
                 </a:solidFill>
+                <a:ea typeface="Microsoft JhengHei"/>
               </a:rPr>
               <a:t>2026 年 1–8 月口徑：GoVision 36%、GoBot＋iRPA 34%、AIoT 30%</a:t>
             </a:r>
@@ -18301,6 +18658,7 @@
                 <a:solidFill>
                   <a:schemeClr val="accent5"/>
                 </a:solidFill>
+                <a:ea typeface="Microsoft JhengHei"/>
               </a:rPr>
               <a:t>Agentic AI 53%／Physical AI 47%</a:t>
             </a:r>
@@ -18409,6 +18767,7 @@
                 <a:solidFill>
                   <a:schemeClr val="accent1"/>
                 </a:solidFill>
+                <a:ea typeface="Microsoft JhengHei"/>
               </a:rPr>
               <a:t>系統架構：三條產品線共用邊緣運算平台</a:t>
             </a:r>
@@ -18466,6 +18825,10 @@
             <a:prstDash val="solid"/>
           </a:ln>
         </p:spPr>
+        <p:txBody>
+          <a:bodyPr/>
+          <a:p/>
+        </p:txBody>
       </p:sp>
       <p:sp>
         <p:nvSpPr>
@@ -18499,6 +18862,7 @@
                 <a:solidFill>
                   <a:schemeClr val="tx1"/>
                 </a:solidFill>
+                <a:ea typeface="Microsoft JhengHei"/>
               </a:rPr>
               <a:t>重點</a:t>
             </a:r>
@@ -18516,6 +18880,7 @@
                 <a:solidFill>
                   <a:schemeClr val="accent5"/>
                 </a:solidFill>
+                <a:ea typeface="Microsoft JhengHei"/>
               </a:rPr>
               <a:t>機台端即時判斷（In-Process），減少回傳延遲</a:t>
             </a:r>
@@ -18533,6 +18898,7 @@
                 <a:solidFill>
                   <a:schemeClr val="accent5"/>
                 </a:solidFill>
+                <a:ea typeface="Microsoft JhengHei"/>
               </a:rPr>
               <a:t>82 品牌、512 機型相容</a:t>
             </a:r>
@@ -18550,6 +18916,7 @@
                 <a:solidFill>
                   <a:schemeClr val="accent5"/>
                 </a:solidFill>
+                <a:ea typeface="Microsoft JhengHei"/>
               </a:rPr>
               <a:t>上接 MES／EAP 與戰情室</a:t>
             </a:r>
@@ -18658,6 +19025,7 @@
                 <a:solidFill>
                   <a:schemeClr val="accent1"/>
                 </a:solidFill>
+                <a:ea typeface="Microsoft JhengHei"/>
               </a:rPr>
               <a:t>GoBot＋iRPA：把 SOP 變成可複製的劇本</a:t>
             </a:r>
@@ -18715,6 +19083,10 @@
             <a:prstDash val="solid"/>
           </a:ln>
         </p:spPr>
+        <p:txBody>
+          <a:bodyPr/>
+          <a:p/>
+        </p:txBody>
       </p:sp>
       <p:sp>
         <p:nvSpPr>
@@ -18748,6 +19120,7 @@
                 <a:solidFill>
                   <a:schemeClr val="tx1"/>
                 </a:solidFill>
+                <a:ea typeface="Microsoft JhengHei"/>
               </a:rPr>
               <a:t>重點</a:t>
             </a:r>
@@ -18765,6 +19138,7 @@
                 <a:solidFill>
                   <a:schemeClr val="accent5"/>
                 </a:solidFill>
+                <a:ea typeface="Microsoft JhengHei"/>
               </a:rPr>
               <a:t>影片自動轉劇本</a:t>
             </a:r>
@@ -18782,6 +19156,7 @@
                 <a:solidFill>
                   <a:schemeClr val="accent5"/>
                 </a:solidFill>
+                <a:ea typeface="Microsoft JhengHei"/>
               </a:rPr>
               <a:t>機差微調後平展上千台</a:t>
             </a:r>
@@ -18799,6 +19174,7 @@
                 <a:solidFill>
                   <a:schemeClr val="accent5"/>
                 </a:solidFill>
+                <a:ea typeface="Microsoft JhengHei"/>
               </a:rPr>
               <a:t>劇本越多、規模效益越大</a:t>
             </a:r>
@@ -18816,6 +19192,7 @@
                 <a:solidFill>
                   <a:schemeClr val="accent5"/>
                 </a:solidFill>
+                <a:ea typeface="Microsoft JhengHei"/>
               </a:rPr>
               <a:t>400+ 種 Alarm 自動排除</a:t>
             </a:r>
@@ -18924,6 +19301,7 @@
                 <a:solidFill>
                   <a:schemeClr val="accent1"/>
                 </a:solidFill>
+                <a:ea typeface="Microsoft JhengHei"/>
               </a:rPr>
               <a:t>GoVision：製程中 AI 感官監控</a:t>
             </a:r>
@@ -18981,6 +19359,10 @@
             <a:prstDash val="solid"/>
           </a:ln>
         </p:spPr>
+        <p:txBody>
+          <a:bodyPr/>
+          <a:p/>
+        </p:txBody>
       </p:sp>
       <p:sp>
         <p:nvSpPr>
@@ -19014,6 +19396,7 @@
                 <a:solidFill>
                   <a:schemeClr val="tx1"/>
                 </a:solidFill>
+                <a:ea typeface="Microsoft JhengHei"/>
               </a:rPr>
               <a:t>重點</a:t>
             </a:r>
@@ -19031,6 +19414,7 @@
                 <a:solidFill>
                   <a:schemeClr val="accent5"/>
                 </a:solidFill>
+                <a:ea typeface="Microsoft JhengHei"/>
               </a:rPr>
               <a:t>已驗證：光阻塗佈軌跡追蹤</a:t>
             </a:r>
@@ -19048,6 +19432,7 @@
                 <a:solidFill>
                   <a:schemeClr val="accent5"/>
                 </a:solidFill>
+                <a:ea typeface="Microsoft JhengHei"/>
               </a:rPr>
               <a:t>視覺偵測水平、裂痕破片、塗佈均勻</a:t>
             </a:r>
@@ -19065,6 +19450,7 @@
                 <a:solidFill>
                   <a:schemeClr val="accent5"/>
                 </a:solidFill>
+                <a:ea typeface="Microsoft JhengHei"/>
               </a:rPr>
               <a:t>聽覺預警、嗅覺監控 VOC</a:t>
             </a:r>
@@ -19082,6 +19468,7 @@
                 <a:solidFill>
                   <a:schemeClr val="accent5"/>
                 </a:solidFill>
+                <a:ea typeface="Microsoft JhengHei"/>
               </a:rPr>
               <a:t>2025 營收 2.58 億（+353%）</a:t>
             </a:r>
@@ -19190,6 +19577,7 @@
                 <a:solidFill>
                   <a:schemeClr val="accent1"/>
                 </a:solidFill>
+                <a:ea typeface="Microsoft JhengHei"/>
               </a:rPr>
               <a:t>自動化演進：從人看機台到 AI 代理</a:t>
             </a:r>
@@ -19247,6 +19635,10 @@
             <a:prstDash val="solid"/>
           </a:ln>
         </p:spPr>
+        <p:txBody>
+          <a:bodyPr/>
+          <a:p/>
+        </p:txBody>
       </p:sp>
       <p:sp>
         <p:nvSpPr>
@@ -19280,6 +19672,7 @@
                 <a:solidFill>
                   <a:schemeClr val="tx1"/>
                 </a:solidFill>
+                <a:ea typeface="Microsoft JhengHei"/>
               </a:rPr>
               <a:t>重點</a:t>
             </a:r>
@@ -19297,6 +19690,7 @@
                 <a:solidFill>
                   <a:schemeClr val="accent5"/>
                 </a:solidFill>
+                <a:ea typeface="Microsoft JhengHei"/>
               </a:rPr>
               <a:t>越往右人員介入越少</a:t>
             </a:r>
@@ -19314,6 +19708,7 @@
                 <a:solidFill>
                   <a:schemeClr val="accent5"/>
                 </a:solidFill>
+                <a:ea typeface="Microsoft JhengHei"/>
               </a:rPr>
               <a:t>預測性維護由選配轉標配</a:t>
             </a:r>
@@ -19331,6 +19726,7 @@
                 <a:solidFill>
                   <a:schemeClr val="accent5"/>
                 </a:solidFill>
+                <a:ea typeface="Microsoft JhengHei"/>
               </a:rPr>
               <a:t>人力節省比例為報導數字，非公司揭露</a:t>
             </a:r>
@@ -19435,7 +19831,7 @@
     <a:fontScheme name="Kevin 07 Teal Trust">
       <a:majorFont>
         <a:latin typeface="Impact"/>
-        <a:ea typeface="Noto Sans TC"/>
+        <a:ea typeface="Microsoft JhengHei"/>
         <a:cs typeface=""/>
         <a:font script="Jpan" typeface="游ゴシック Light"/>
         <a:font script="Hang" typeface="맑은 고딕"/>
@@ -19487,7 +19883,7 @@
       </a:majorFont>
       <a:minorFont>
         <a:latin typeface="Arial"/>
-        <a:ea typeface="Noto Sans TC"/>
+        <a:ea typeface="Microsoft JhengHei"/>
         <a:cs typeface=""/>
         <a:font script="Jpan" typeface="游ゴシック"/>
         <a:font script="Hang" typeface="맑은 고딕"/>

</xml_diff>